<commit_message>
Fill in real evaluation results
</commit_message>
<xml_diff>
--- a/docs/slides/CJEU_RAG_presentation.pptx
+++ b/docs/slides/CJEU_RAG_presentation.pptx
@@ -2287,7 +2287,7 @@
                 <a:ea typeface="Calibri" pitchFamily="34" charset="-122"/>
                 <a:cs typeface="Calibri" pitchFamily="34" charset="-120"/>
               </a:rPr>
-              <a:t>Open question</a:t>
+              <a:t>What the data shows so far</a:t>
             </a:r>
             <a:endParaRPr lang="en-US" sz="1400" dirty="0"/>
           </a:p>
@@ -2326,7 +2326,7 @@
                 <a:ea typeface="Calibri" pitchFamily="34" charset="-122"/>
                 <a:cs typeface="Calibri" pitchFamily="34" charset="-120"/>
               </a:rPr>
-              <a:t>Fill in after the batch runs: does the multi-agent's “consult both when ambiguous” rule measurably improve cross-domain answers (guide's Q02/Q04/Q09-style) enough to justify the latency?</a:t>
+              <a:t>Faithfulness and relevancy proxies are close between the two (within ~0.02); the raw latency gap favors multi-agent, but it's confounded by rate-limit waits and one single-agent outlier question — not yet a clean result. Needs a rerun outside rate-limiting to trust the latency comparison.</a:t>
             </a:r>
             <a:endParaRPr lang="en-US" sz="1250" dirty="0"/>
           </a:p>
@@ -7963,7 +7963,7 @@
                 <a:ea typeface="Calibri" pitchFamily="34" charset="-122"/>
                 <a:cs typeface="Calibri" pitchFamily="34" charset="-120"/>
               </a:rPr>
-              <a:t>RESULTS — FILL IN AFTER BATCH_RUN.PY</a:t>
+              <a:t>RESULTS — GUIDE'S 20 EXAMPLE QUESTIONS, 2026-07-23</a:t>
             </a:r>
             <a:endParaRPr lang="en-US" sz="1200" dirty="0"/>
           </a:p>
@@ -8293,7 +8293,7 @@
                             <a:srgbClr val="1E2761"/>
                           </a:solidFill>
                         </a:rPr>
-                        <a:t>TBD</a:t>
+                        <a:t>0.740</a:t>
                       </a:r>
                       <a:endParaRPr lang="en-US" sz="1200" dirty="0"/>
                     </a:p>
@@ -8351,7 +8351,7 @@
                             <a:srgbClr val="1E2761"/>
                           </a:solidFill>
                         </a:rPr>
-                        <a:t>TBD</a:t>
+                        <a:t>0.716</a:t>
                       </a:r>
                       <a:endParaRPr lang="en-US" sz="1200" dirty="0"/>
                     </a:p>
@@ -8469,7 +8469,7 @@
                             <a:srgbClr val="1E2761"/>
                           </a:solidFill>
                         </a:rPr>
-                        <a:t>TBD</a:t>
+                        <a:t>0.974</a:t>
                       </a:r>
                       <a:endParaRPr lang="en-US" sz="1200" dirty="0"/>
                     </a:p>
@@ -8527,7 +8527,7 @@
                             <a:srgbClr val="1E2761"/>
                           </a:solidFill>
                         </a:rPr>
-                        <a:t>TBD</a:t>
+                        <a:t>0.958</a:t>
                       </a:r>
                       <a:endParaRPr lang="en-US" sz="1200" dirty="0"/>
                     </a:p>
@@ -8645,7 +8645,7 @@
                             <a:srgbClr val="1E2761"/>
                           </a:solidFill>
                         </a:rPr>
-                        <a:t>TBD</a:t>
+                        <a:t>0.803</a:t>
                       </a:r>
                       <a:endParaRPr lang="en-US" sz="1200" dirty="0"/>
                     </a:p>
@@ -8703,7 +8703,7 @@
                             <a:srgbClr val="1E2761"/>
                           </a:solidFill>
                         </a:rPr>
-                        <a:t>TBD</a:t>
+                        <a:t>0.785</a:t>
                       </a:r>
                       <a:endParaRPr lang="en-US" sz="1200" dirty="0"/>
                     </a:p>
@@ -8821,7 +8821,7 @@
                             <a:srgbClr val="1E2761"/>
                           </a:solidFill>
                         </a:rPr>
-                        <a:t>TBD</a:t>
+                        <a:t>44.9</a:t>
                       </a:r>
                       <a:endParaRPr lang="en-US" sz="1200" dirty="0"/>
                     </a:p>
@@ -8879,7 +8879,7 @@
                             <a:srgbClr val="1E2761"/>
                           </a:solidFill>
                         </a:rPr>
-                        <a:t>TBD</a:t>
+                        <a:t>27.3</a:t>
                       </a:r>
                       <a:endParaRPr lang="en-US" sz="1200" dirty="0"/>
                     </a:p>
@@ -8997,7 +8997,7 @@
                             <a:srgbClr val="1E2761"/>
                           </a:solidFill>
                         </a:rPr>
-                        <a:t>TBD</a:t>
+                        <a:t>0.20 (4/20)</a:t>
                       </a:r>
                       <a:endParaRPr lang="en-US" sz="1200" dirty="0"/>
                     </a:p>
@@ -9055,7 +9055,7 @@
                             <a:srgbClr val="1E2761"/>
                           </a:solidFill>
                         </a:rPr>
-                        <a:t>TBD</a:t>
+                        <a:t>0.10 (2/20)</a:t>
                       </a:r>
                       <a:endParaRPr lang="en-US" sz="1200" dirty="0"/>
                     </a:p>
@@ -9112,24 +9112,24 @@
         </p:nvSpPr>
         <p:spPr>
           <a:xfrm>
-            <a:off x="1371600" y="5120640"/>
-            <a:ext cx="8229600" cy="640080"/>
-          </a:xfrm>
-          <a:prstGeom prst="rect">
-            <a:avLst/>
-          </a:prstGeom>
-          <a:noFill/>
-          <a:ln/>
-        </p:spPr>
-        <p:txBody>
-          <a:bodyPr wrap="square" lIns="0" tIns="0" rIns="0" bIns="0" rtlCol="0" anchor="ctr"/>
+            <a:off x="1371600" y="4846320"/>
+            <a:ext cx="8229600" cy="914400"/>
+          </a:xfrm>
+          <a:prstGeom prst="rect">
+            <a:avLst/>
+          </a:prstGeom>
+          <a:noFill/>
+          <a:ln/>
+        </p:spPr>
+        <p:txBody>
+          <a:bodyPr wrap="square" lIns="0" tIns="0" rIns="0" bIns="0" rtlCol="0" anchor="t"/>
           <a:lstStyle/>
           <a:p>
             <a:pPr algn="ctr" indent="0" marL="0">
               <a:buNone/>
             </a:pPr>
             <a:r>
-              <a:rPr lang="en-US" sz="1200" i="1" dirty="0">
+              <a:rPr lang="en-US" sz="1100" i="1" dirty="0">
                 <a:solidFill>
                   <a:srgbClr val="5B6B9E"/>
                 </a:solidFill>
@@ -9137,9 +9137,9 @@
                 <a:ea typeface="Calibri" pitchFamily="34" charset="-122"/>
                 <a:cs typeface="Calibri" pitchFamily="34" charset="-120"/>
               </a:rPr>
-              <a:t>Run python src/evaluation/batch_run.py --system single_agent (and --system multi_agent), then read the aggregate comparison off src/evaluation/dashboard.py to fill this table in.</a:t>
-            </a:r>
-            <a:endParaRPr lang="en-US" sz="1200" dirty="0"/>
+              <a:t>Caveat on latency: both runs hit Gemini's free-tier rate limit repeatedly (retry waits are included in the logged time), and the single-agent run has one outlier question (“latest judgment”) that returned a near-complete case list as “sources”, inflating both its latency and avg. source count. Not a clean architectural comparison as-is — see docs/performance_table.md.</a:t>
+            </a:r>
+            <a:endParaRPr lang="en-US" sz="1100" dirty="0"/>
           </a:p>
         </p:txBody>
       </p:sp>
@@ -9151,7 +9151,7 @@
         </p:nvSpPr>
         <p:spPr>
           <a:xfrm>
-            <a:off x="1371600" y="5852160"/>
+            <a:off x="1371600" y="5943600"/>
             <a:ext cx="8229600" cy="365760"/>
           </a:xfrm>
           <a:prstGeom prst="rect">

</xml_diff>